<commit_message>
docs: reemplazar capturas moviles obsoletas
</commit_message>
<xml_diff>
--- a/TI.1.3. PAO202651_RESTFUL_JAVA_SINBDD_NRC36884_GR09/05. DOCUMENTACION/CONVUNI_RESTFUL_JAVA_GR09.pptx
+++ b/TI.1.3. PAO202651_RESTFUL_JAVA_SINBDD_NRC36884_GR09/05. DOCUMENTACION/CONVUNI_RESTFUL_JAVA_GR09.pptx
@@ -30579,7 +30579,7 @@
 </file>
 
 <file path=ppt/slides/slide27.xml><?xml version="1.0" encoding="utf-8"?>
-<p:sld xmlns:a="http://schemas.openxmlformats.org/drawingml/2006/main" xmlns:r="http://schemas.openxmlformats.org/officeDocument/2006/relationships" xmlns:p="http://schemas.openxmlformats.org/presentationml/2006/main">
+<p:sld xmlns:a="http://schemas.openxmlformats.org/drawingml/2006/main" xmlns:p="http://schemas.openxmlformats.org/presentationml/2006/main" xmlns:r="http://schemas.openxmlformats.org/officeDocument/2006/relationships">
   <p:cSld>
     <p:spTree>
       <p:nvGrpSpPr>
@@ -31269,34 +31269,6 @@
       </p:sp>
       <p:pic>
         <p:nvPicPr>
-          <p:cNvPr id="459" name="image50.png"/>
-          <p:cNvPicPr/>
-          <p:nvPr/>
-        </p:nvPicPr>
-        <p:blipFill>
-          <a:blip r:embed="rId3"/>
-          <a:srcRect/>
-          <a:stretch>
-            <a:fillRect/>
-          </a:stretch>
-        </p:blipFill>
-        <p:spPr>
-          <a:xfrm>
-            <a:off x="5096586" y="3395466"/>
-            <a:ext cx="3346888" cy="3121255"/>
-          </a:xfrm>
-          <a:prstGeom prst="rect">
-            <a:avLst/>
-          </a:prstGeom>
-          <a:ln w="12700">
-            <a:solidFill>
-              <a:srgbClr val="CCCCCC"/>
-            </a:solidFill>
-          </a:ln>
-        </p:spPr>
-      </p:pic>
-      <p:pic>
-        <p:nvPicPr>
           <p:cNvPr id="460" name="image51.png"/>
           <p:cNvPicPr/>
           <p:nvPr/>
@@ -31332,7 +31304,7 @@
 </file>
 
 <file path=ppt/slides/slide28.xml><?xml version="1.0" encoding="utf-8"?>
-<p:sld xmlns:a="http://schemas.openxmlformats.org/drawingml/2006/main" xmlns:r="http://schemas.openxmlformats.org/officeDocument/2006/relationships" xmlns:p="http://schemas.openxmlformats.org/presentationml/2006/main">
+<p:sld xmlns:a="http://schemas.openxmlformats.org/drawingml/2006/main" xmlns:p="http://schemas.openxmlformats.org/presentationml/2006/main" xmlns:r="http://schemas.openxmlformats.org/officeDocument/2006/relationships">
   <p:cSld>
     <p:spTree>
       <p:nvGrpSpPr>
@@ -31913,34 +31885,6 @@
           </a:p>
         </p:txBody>
       </p:sp>
-      <p:pic>
-        <p:nvPicPr>
-          <p:cNvPr id="496" name="image50.png"/>
-          <p:cNvPicPr/>
-          <p:nvPr/>
-        </p:nvPicPr>
-        <p:blipFill>
-          <a:blip r:embed="rId3"/>
-          <a:srcRect/>
-          <a:stretch>
-            <a:fillRect/>
-          </a:stretch>
-        </p:blipFill>
-        <p:spPr>
-          <a:xfrm>
-            <a:off x="4375360" y="3132224"/>
-            <a:ext cx="1577205" cy="3469750"/>
-          </a:xfrm>
-          <a:prstGeom prst="rect">
-            <a:avLst/>
-          </a:prstGeom>
-          <a:ln w="12700">
-            <a:solidFill>
-              <a:srgbClr val="CCCCCC"/>
-            </a:solidFill>
-          </a:ln>
-        </p:spPr>
-      </p:pic>
       <p:pic>
         <p:nvPicPr>
           <p:cNvPr id="497" name="image51.png"/>

</xml_diff>